<commit_message>
Update presentation with live S3 results; ignore Office lock files
Co-Authored-By: Claude Opus 5.5 <noreply@anthropic.com>
</commit_message>
<xml_diff>
--- a/docs/presentation/Sync-Agent-How-It-Works.pptx
+++ b/docs/presentation/Sync-Agent-How-It-Works.pptx
@@ -937,7 +937,7 @@
           <a:lstStyle/>
           <a:p>
             <a:r>
-              <a:t>Every build runs 211 automated tests and refuses to package on failure. A one-command acceptance script installs, starts, stops, upgrades and uninstalls the real installer in throwaway folders: 20 of 20 checks pass on Windows 11, and the same command is ready for Windows 10. Code signing is wired into the build and CI and was proven with a test certificate; it needs a real certificate. The live S3 end-to-end test is written and self-cleaning, and needs a valid AWS test key.</a:t>
+              <a:t>Every build runs 217 automated tests and refuses to package on failure. A one-command acceptance script installs, starts, stops, upgrades and uninstalls the real installer in throwaway folders: 20 of 20 checks pass on Windows 11, and the same command is ready for Windows 10. Code signing is wired into the build and CI and was proven with a test certificate; it needs a real certificate. The live S3 tests passed against a real test bucket: conditional writes plus a full end-to-end sync, with every test object cleaned up afterwards.</a:t>
             </a:r>
           </a:p>
         </p:txBody>
@@ -10359,7 +10359,7 @@
                 </a:solidFill>
                 <a:latin typeface="Segoe UI Semibold"/>
               </a:rPr>
-              <a:t>211</a:t>
+              <a:t>217</a:t>
             </a:r>
           </a:p>
         </p:txBody>
@@ -11268,7 +11268,7 @@
             </a:avLst>
           </a:prstGeom>
           <a:solidFill>
-            <a:srgbClr val="FEF3C7"/>
+            <a:srgbClr val="FFFFFF"/>
           </a:solidFill>
           <a:ln w="15875">
             <a:solidFill>
@@ -11378,7 +11378,7 @@
                 </a:solidFill>
                 <a:latin typeface="Segoe UI"/>
               </a:rPr>
-              <a:t>Real end-to-end sync test, unique prefix, self-cleaning</a:t>
+              <a:t>Real end-to-end sync against a test bucket, self-cleaning</a:t>
             </a:r>
           </a:p>
         </p:txBody>
@@ -11400,7 +11400,7 @@
             </a:avLst>
           </a:prstGeom>
           <a:solidFill>
-            <a:srgbClr val="B45309"/>
+            <a:srgbClr val="15803D"/>
           </a:solidFill>
           <a:ln>
             <a:noFill/>
@@ -11440,7 +11440,7 @@
                 </a:solidFill>
                 <a:latin typeface="Segoe UI Semibold"/>
               </a:rPr>
-              <a:t>Needs valid test key</a:t>
+              <a:t>Passed</a:t>
             </a:r>
           </a:p>
         </p:txBody>
@@ -12091,25 +12091,6 @@
                 <a:latin typeface="Segoe UI"/>
               </a:rPr>
               <a:t>•  Run acceptance on Windows 10</a:t>
-            </a:r>
-          </a:p>
-          <a:p>
-            <a:pPr algn="l">
-              <a:lnSpc>
-                <a:spcPct val="110000"/>
-              </a:lnSpc>
-              <a:spcAft>
-                <a:spcPts val="600"/>
-              </a:spcAft>
-            </a:pPr>
-            <a:r>
-              <a:rPr sz="1500" b="0">
-                <a:solidFill>
-                  <a:srgbClr val="FFFFFF"/>
-                </a:solidFill>
-                <a:latin typeface="Segoe UI"/>
-              </a:rPr>
-              <a:t>•  New AWS test key → live S3 test</a:t>
             </a:r>
           </a:p>
           <a:p>

</xml_diff>